<commit_message>
Finalize SwiftLog Week 5 ML engineering project
</commit_message>
<xml_diff>
--- a/Presentation/Executive_Presentation.pptx
+++ b/Presentation/Executive_Presentation.pptx
@@ -3515,7 +3515,7 @@
               </a:defRPr>
             </a:pPr>
             <a:r>
-              <a:t>Selected: Random Forest (tuned) | F1 0.905 | ROC-AUC 0.512</a:t>
+              <a:t>Selected: Random Forest (tuned) | F1 0.904 | ROC-AUC 0.496</a:t>
             </a:r>
           </a:p>
         </p:txBody>
@@ -3694,7 +3694,7 @@
               </a:defRPr>
             </a:pPr>
             <a:r>
-              <a:t>Selected: Logistic Regression | F1 0.163 | ROC-AUC 0.488</a:t>
+              <a:t>Selected: Decision Tree | F1 0.161 | ROC-AUC 0.481</a:t>
             </a:r>
           </a:p>
         </p:txBody>
@@ -3873,12 +3873,12 @@
               </a:defRPr>
             </a:pPr>
             <a:r>
-              <a:t>Selected: Random Forest Regressor (tuned) | MAE 6.52 | RMSE 8.08 | R-squared -0.014</a:t>
-            </a:r>
-          </a:p>
-          <a:p>
-            <a:r>
-              <a:t>Selected: Linear Regression | MAE 2990.71 | RMSE 3757.00 | R-squared -0.069</a:t>
+              <a:t>Selected: Random Forest Regressor (tuned) | MAE 6.40 | RMSE 7.96 | R-squared -0.028</a:t>
+            </a:r>
+          </a:p>
+          <a:p>
+            <a:r>
+              <a:t>Selected: Linear Regression | MAE 3160.40 | RMSE 4082.08 | R-squared 0.001</a:t>
             </a:r>
           </a:p>
         </p:txBody>

</xml_diff>

<commit_message>
Fix report generation and refresh Week 5 deliverables
</commit_message>
<xml_diff>
--- a/Presentation/Executive_Presentation.pptx
+++ b/Presentation/Executive_Presentation.pptx
@@ -3371,7 +3371,7 @@
               </a:defRPr>
             </a:pPr>
             <a:r>
-              <a:t>Compared Logistic Regression, Decision Tree, and Random Forest for classification; Linear Regression, Decision Tree Regressor, and Random Forest Regressor for regression.</a:t>
+              <a:t>Compared classification and regression algorithms using held-out evaluation. Classification uses accuracy, precision, recall, F1, and ROC-AUC where available; regression uses MAE, RMSE, and R-squared.</a:t>
             </a:r>
           </a:p>
         </p:txBody>
@@ -3515,7 +3515,7 @@
               </a:defRPr>
             </a:pPr>
             <a:r>
-              <a:t>Selected: Random Forest (tuned) | F1 0.904 | ROC-AUC 0.496</a:t>
+              <a:t>Selected: Random Forest (tuned) | Accuracy 0.852 | Precision 0.879 | Recall 0.964 | F1 0.920 | ROC-AUC 0.506</a:t>
             </a:r>
           </a:p>
         </p:txBody>
@@ -3550,7 +3550,7 @@
               </a:defRPr>
             </a:pPr>
             <a:r>
-              <a:t>ROC-AUC near 0.5 means weak class discrimination despite the high F1 score.</a:t>
+              <a:t>ROC-AUC near 0.5 means weak class discrimination despite a high F1 score.</a:t>
             </a:r>
           </a:p>
         </p:txBody>
@@ -3694,7 +3694,7 @@
               </a:defRPr>
             </a:pPr>
             <a:r>
-              <a:t>Selected: Decision Tree | F1 0.161 | ROC-AUC 0.481</a:t>
+              <a:t>Selected: Decision Tree | Accuracy 0.424 | Precision 0.086 | Recall 0.526 | F1 0.148 | ROC-AUC 0.478</a:t>
             </a:r>
           </a:p>
         </p:txBody>
@@ -3873,12 +3873,12 @@
               </a:defRPr>
             </a:pPr>
             <a:r>
-              <a:t>Selected: Random Forest Regressor (tuned) | MAE 6.40 | RMSE 7.96 | R-squared -0.028</a:t>
-            </a:r>
-          </a:p>
-          <a:p>
-            <a:r>
-              <a:t>Selected: Linear Regression | MAE 3160.40 | RMSE 4082.08 | R-squared 0.001</a:t>
+              <a:t>Selected: Random Forest Regressor (tuned) | MAE 6.53 | RMSE 8.07 | R-squared -0.012</a:t>
+            </a:r>
+          </a:p>
+          <a:p>
+            <a:r>
+              <a:t>Selected: Linear Regression | MAE 2990.71 | RMSE 3757.00 | R-squared -0.069</a:t>
             </a:r>
           </a:p>
         </p:txBody>
@@ -4057,7 +4057,7 @@
               </a:defRPr>
             </a:pPr>
             <a:r>
-              <a:t>Improve delivery timestamps, reconcile status and delay fields, link suppliers to shipments, collect inventory snapshots, and define consistent return labels.</a:t>
+              <a:t>Improve delivery timestamps, reconcile status and delay fields, link suppliers to relevant records, collect inventory snapshots, and define consistent return labels.</a:t>
             </a:r>
           </a:p>
         </p:txBody>
@@ -4201,7 +4201,7 @@
               </a:defRPr>
             </a:pPr>
             <a:r>
-              <a:t>The workflow and demo app are complete as a prototype. Collect more history, improve predictors, validate on future periods, and require human review before operational use.</a:t>
+              <a:t>The workflow and demo app form an educational prototype. Collect more history, improve predictors, validate on future periods, and require human review before operational use.</a:t>
             </a:r>
           </a:p>
         </p:txBody>
@@ -4921,7 +4921,7 @@
               </a:defRPr>
             </a:pPr>
             <a:r>
-              <a:t>Target: DelayDays greater than zero. Predictors include warehouse, location, customer city, and order-date parts. DelayDays itself is excluded from the inputs.</a:t>
+              <a:t>Target: DelayDays greater than zero. Predictors include available warehouse, location, customer-city, and order-date information. DelayDays itself is excluded from the inputs.</a:t>
             </a:r>
           </a:p>
         </p:txBody>
@@ -5065,7 +5065,7 @@
               </a:defRPr>
             </a:pPr>
             <a:r>
-              <a:t>Target: order appears in the Returns table. Predictors include order timing, city, and item-level aggregates available from the order.</a:t>
+              <a:t>Target: order appears in the Returns table. Predictors include available order timing, city, and item-level aggregates.</a:t>
             </a:r>
           </a:p>
         </p:txBody>
@@ -5209,7 +5209,7 @@
               </a:defRPr>
             </a:pPr>
             <a:r>
-              <a:t>Target: product units per week. Features use prior-week demand, demand four weeks earlier, and a rolling average of the four previous weeks.</a:t>
+              <a:t>Target: product units per week. Features use prior-week demand, demand four weeks earlier, and a rolling average of prior weeks.</a:t>
             </a:r>
           </a:p>
         </p:txBody>

</xml_diff>